<commit_message>
docs: add Presto logo to the decks
</commit_message>
<xml_diff>
--- a/docs/presentacion-corta.pptx
+++ b/docs/presentacion-corta.pptx
@@ -4013,60 +4013,30 @@
         <p:nvPr/>
       </p:nvGrpSpPr>
       <p:grpSpPr/>
-      <p:sp>
-        <p:nvSpPr>
-          <p:cNvPr id="2" name="Rounded Rectangle 1"/>
-          <p:cNvSpPr/>
+      <p:pic>
+        <p:nvPicPr>
+          <p:cNvPr id="2" name="Picture 1" descr="presto-logo.png"/>
+          <p:cNvPicPr>
+            <a:picLocks noChangeAspect="1"/>
+          </p:cNvPicPr>
           <p:nvPr/>
-        </p:nvSpPr>
-        <p:spPr>
-          <a:xfrm>
-            <a:off x="777240" y="914400"/>
-            <a:ext cx="868680" cy="868680"/>
-          </a:xfrm>
-          <a:prstGeom prst="roundRect">
-            <a:avLst>
-              <a:gd name="adj" fmla="val 8000"/>
-            </a:avLst>
-          </a:prstGeom>
-          <a:solidFill>
-            <a:srgbClr val="465FFF"/>
-          </a:solidFill>
-          <a:ln>
-            <a:noFill/>
-          </a:ln>
-        </p:spPr>
-        <p:style>
-          <a:lnRef idx="1">
-            <a:schemeClr val="accent1"/>
-          </a:lnRef>
-          <a:fillRef idx="3">
-            <a:schemeClr val="accent1"/>
-          </a:fillRef>
-          <a:effectRef idx="2">
-            <a:schemeClr val="accent1"/>
-          </a:effectRef>
-          <a:fontRef idx="minor">
-            <a:schemeClr val="lt1"/>
-          </a:fontRef>
-        </p:style>
-        <p:txBody>
-          <a:bodyPr rtlCol="0" anchor="ctr" wrap="square"/>
-          <a:lstStyle/>
-          <a:p>
-            <a:pPr algn="ctr"/>
-            <a:r>
-              <a:rPr sz="4000" b="1">
-                <a:solidFill>
-                  <a:srgbClr val="FFFFFF"/>
-                </a:solidFill>
-                <a:latin typeface="Segoe UI"/>
-              </a:rPr>
-              <a:t>P</a:t>
-            </a:r>
-          </a:p>
-        </p:txBody>
-      </p:sp>
+        </p:nvPicPr>
+        <p:blipFill>
+          <a:blip r:embed="rId2"/>
+          <a:stretch>
+            <a:fillRect/>
+          </a:stretch>
+        </p:blipFill>
+        <p:spPr>
+          <a:xfrm>
+            <a:off x="777240" y="868680"/>
+            <a:ext cx="960120" cy="960120"/>
+          </a:xfrm>
+          <a:prstGeom prst="rect">
+            <a:avLst/>
+          </a:prstGeom>
+        </p:spPr>
+      </p:pic>
       <p:sp>
         <p:nvSpPr>
           <p:cNvPr id="3" name="TextBox 2"/>
@@ -4347,15 +4317,39 @@
         <p:nvPr/>
       </p:nvGrpSpPr>
       <p:grpSpPr/>
-      <p:sp>
-        <p:nvSpPr>
-          <p:cNvPr id="2" name="TextBox 1"/>
+      <p:pic>
+        <p:nvPicPr>
+          <p:cNvPr id="2" name="Picture 1" descr="presto-logo.png"/>
+          <p:cNvPicPr>
+            <a:picLocks noChangeAspect="1"/>
+          </p:cNvPicPr>
+          <p:nvPr/>
+        </p:nvPicPr>
+        <p:blipFill>
+          <a:blip r:embed="rId2"/>
+          <a:stretch>
+            <a:fillRect/>
+          </a:stretch>
+        </p:blipFill>
+        <p:spPr>
+          <a:xfrm>
+            <a:off x="502920" y="182880"/>
+            <a:ext cx="420624" cy="420624"/>
+          </a:xfrm>
+          <a:prstGeom prst="rect">
+            <a:avLst/>
+          </a:prstGeom>
+        </p:spPr>
+      </p:pic>
+      <p:sp>
+        <p:nvSpPr>
+          <p:cNvPr id="3" name="TextBox 2"/>
           <p:cNvSpPr txBox="1"/>
           <p:nvPr/>
         </p:nvSpPr>
         <p:spPr>
           <a:xfrm>
-            <a:off x="502920" y="301752"/>
+            <a:off x="1024128" y="301752"/>
             <a:ext cx="2743200" cy="228600"/>
           </a:xfrm>
           <a:prstGeom prst="rect">
@@ -4388,7 +4382,7 @@
       </p:sp>
       <p:sp>
         <p:nvSpPr>
-          <p:cNvPr id="3" name="TextBox 2"/>
+          <p:cNvPr id="4" name="TextBox 3"/>
           <p:cNvSpPr txBox="1"/>
           <p:nvPr/>
         </p:nvSpPr>
@@ -4427,7 +4421,7 @@
       </p:sp>
       <p:sp>
         <p:nvSpPr>
-          <p:cNvPr id="4" name="TextBox 3"/>
+          <p:cNvPr id="5" name="TextBox 4"/>
           <p:cNvSpPr txBox="1"/>
           <p:nvPr/>
         </p:nvSpPr>
@@ -4466,7 +4460,7 @@
       </p:sp>
       <p:sp>
         <p:nvSpPr>
-          <p:cNvPr id="5" name="Rectangle 4"/>
+          <p:cNvPr id="6" name="Rectangle 5"/>
           <p:cNvSpPr/>
           <p:nvPr/>
         </p:nvSpPr>
@@ -4509,7 +4503,7 @@
       </p:sp>
       <p:sp>
         <p:nvSpPr>
-          <p:cNvPr id="6" name="TextBox 5"/>
+          <p:cNvPr id="7" name="TextBox 6"/>
           <p:cNvSpPr txBox="1"/>
           <p:nvPr/>
         </p:nvSpPr>
@@ -4548,7 +4542,7 @@
       </p:sp>
       <p:sp>
         <p:nvSpPr>
-          <p:cNvPr id="7" name="TextBox 6"/>
+          <p:cNvPr id="8" name="TextBox 7"/>
           <p:cNvSpPr txBox="1"/>
           <p:nvPr/>
         </p:nvSpPr>
@@ -4587,7 +4581,7 @@
       </p:sp>
       <p:sp>
         <p:nvSpPr>
-          <p:cNvPr id="8" name="TextBox 7"/>
+          <p:cNvPr id="9" name="TextBox 8"/>
           <p:cNvSpPr txBox="1"/>
           <p:nvPr/>
         </p:nvSpPr>
@@ -4628,7 +4622,7 @@
       </p:sp>
       <p:sp>
         <p:nvSpPr>
-          <p:cNvPr id="9" name="Rounded Rectangle 8"/>
+          <p:cNvPr id="10" name="Rounded Rectangle 9"/>
           <p:cNvSpPr/>
           <p:nvPr/>
         </p:nvSpPr>
@@ -4706,15 +4700,39 @@
         <p:nvPr/>
       </p:nvGrpSpPr>
       <p:grpSpPr/>
-      <p:sp>
-        <p:nvSpPr>
-          <p:cNvPr id="2" name="TextBox 1"/>
+      <p:pic>
+        <p:nvPicPr>
+          <p:cNvPr id="2" name="Picture 1" descr="presto-logo.png"/>
+          <p:cNvPicPr>
+            <a:picLocks noChangeAspect="1"/>
+          </p:cNvPicPr>
+          <p:nvPr/>
+        </p:nvPicPr>
+        <p:blipFill>
+          <a:blip r:embed="rId2"/>
+          <a:stretch>
+            <a:fillRect/>
+          </a:stretch>
+        </p:blipFill>
+        <p:spPr>
+          <a:xfrm>
+            <a:off x="502920" y="182880"/>
+            <a:ext cx="420624" cy="420624"/>
+          </a:xfrm>
+          <a:prstGeom prst="rect">
+            <a:avLst/>
+          </a:prstGeom>
+        </p:spPr>
+      </p:pic>
+      <p:sp>
+        <p:nvSpPr>
+          <p:cNvPr id="3" name="TextBox 2"/>
           <p:cNvSpPr txBox="1"/>
           <p:nvPr/>
         </p:nvSpPr>
         <p:spPr>
           <a:xfrm>
-            <a:off x="502920" y="301752"/>
+            <a:off x="1024128" y="301752"/>
             <a:ext cx="2743200" cy="228600"/>
           </a:xfrm>
           <a:prstGeom prst="rect">
@@ -4747,7 +4765,7 @@
       </p:sp>
       <p:sp>
         <p:nvSpPr>
-          <p:cNvPr id="3" name="TextBox 2"/>
+          <p:cNvPr id="4" name="TextBox 3"/>
           <p:cNvSpPr txBox="1"/>
           <p:nvPr/>
         </p:nvSpPr>
@@ -4786,7 +4804,7 @@
       </p:sp>
       <p:sp>
         <p:nvSpPr>
-          <p:cNvPr id="4" name="TextBox 3"/>
+          <p:cNvPr id="5" name="TextBox 4"/>
           <p:cNvSpPr txBox="1"/>
           <p:nvPr/>
         </p:nvSpPr>
@@ -4825,7 +4843,7 @@
       </p:sp>
       <p:sp>
         <p:nvSpPr>
-          <p:cNvPr id="5" name="Rectangle 4"/>
+          <p:cNvPr id="6" name="Rectangle 5"/>
           <p:cNvSpPr/>
           <p:nvPr/>
         </p:nvSpPr>
@@ -4868,7 +4886,7 @@
       </p:sp>
       <p:sp>
         <p:nvSpPr>
-          <p:cNvPr id="6" name="TextBox 5"/>
+          <p:cNvPr id="7" name="TextBox 6"/>
           <p:cNvSpPr txBox="1"/>
           <p:nvPr/>
         </p:nvSpPr>
@@ -4907,7 +4925,7 @@
       </p:sp>
       <p:sp>
         <p:nvSpPr>
-          <p:cNvPr id="7" name="TextBox 6"/>
+          <p:cNvPr id="8" name="TextBox 7"/>
           <p:cNvSpPr txBox="1"/>
           <p:nvPr/>
         </p:nvSpPr>
@@ -4946,7 +4964,7 @@
       </p:sp>
       <p:sp>
         <p:nvSpPr>
-          <p:cNvPr id="8" name="TextBox 7"/>
+          <p:cNvPr id="9" name="TextBox 8"/>
           <p:cNvSpPr txBox="1"/>
           <p:nvPr/>
         </p:nvSpPr>
@@ -4985,7 +5003,7 @@
       </p:sp>
       <p:sp>
         <p:nvSpPr>
-          <p:cNvPr id="9" name="Rounded Rectangle 8"/>
+          <p:cNvPr id="10" name="Rounded Rectangle 9"/>
           <p:cNvSpPr/>
           <p:nvPr/>
         </p:nvSpPr>
@@ -5061,7 +5079,7 @@
       </p:sp>
       <p:sp>
         <p:nvSpPr>
-          <p:cNvPr id="10" name="Rounded Rectangle 9"/>
+          <p:cNvPr id="11" name="Rounded Rectangle 10"/>
           <p:cNvSpPr/>
           <p:nvPr/>
         </p:nvSpPr>
@@ -5137,7 +5155,7 @@
       </p:sp>
       <p:sp>
         <p:nvSpPr>
-          <p:cNvPr id="11" name="Rounded Rectangle 10"/>
+          <p:cNvPr id="12" name="Rounded Rectangle 11"/>
           <p:cNvSpPr/>
           <p:nvPr/>
         </p:nvSpPr>
@@ -5213,7 +5231,7 @@
       </p:sp>
       <p:sp>
         <p:nvSpPr>
-          <p:cNvPr id="12" name="Rounded Rectangle 11"/>
+          <p:cNvPr id="13" name="Rounded Rectangle 12"/>
           <p:cNvSpPr/>
           <p:nvPr/>
         </p:nvSpPr>
@@ -5289,7 +5307,7 @@
       </p:sp>
       <p:sp>
         <p:nvSpPr>
-          <p:cNvPr id="13" name="Rounded Rectangle 12"/>
+          <p:cNvPr id="14" name="Rounded Rectangle 13"/>
           <p:cNvSpPr/>
           <p:nvPr/>
         </p:nvSpPr>
@@ -5367,15 +5385,39 @@
         <p:nvPr/>
       </p:nvGrpSpPr>
       <p:grpSpPr/>
-      <p:sp>
-        <p:nvSpPr>
-          <p:cNvPr id="2" name="TextBox 1"/>
+      <p:pic>
+        <p:nvPicPr>
+          <p:cNvPr id="2" name="Picture 1" descr="presto-logo.png"/>
+          <p:cNvPicPr>
+            <a:picLocks noChangeAspect="1"/>
+          </p:cNvPicPr>
+          <p:nvPr/>
+        </p:nvPicPr>
+        <p:blipFill>
+          <a:blip r:embed="rId2"/>
+          <a:stretch>
+            <a:fillRect/>
+          </a:stretch>
+        </p:blipFill>
+        <p:spPr>
+          <a:xfrm>
+            <a:off x="502920" y="182880"/>
+            <a:ext cx="420624" cy="420624"/>
+          </a:xfrm>
+          <a:prstGeom prst="rect">
+            <a:avLst/>
+          </a:prstGeom>
+        </p:spPr>
+      </p:pic>
+      <p:sp>
+        <p:nvSpPr>
+          <p:cNvPr id="3" name="TextBox 2"/>
           <p:cNvSpPr txBox="1"/>
           <p:nvPr/>
         </p:nvSpPr>
         <p:spPr>
           <a:xfrm>
-            <a:off x="502920" y="301752"/>
+            <a:off x="1024128" y="301752"/>
             <a:ext cx="2743200" cy="228600"/>
           </a:xfrm>
           <a:prstGeom prst="rect">
@@ -5408,7 +5450,7 @@
       </p:sp>
       <p:sp>
         <p:nvSpPr>
-          <p:cNvPr id="3" name="TextBox 2"/>
+          <p:cNvPr id="4" name="TextBox 3"/>
           <p:cNvSpPr txBox="1"/>
           <p:nvPr/>
         </p:nvSpPr>
@@ -5447,7 +5489,7 @@
       </p:sp>
       <p:sp>
         <p:nvSpPr>
-          <p:cNvPr id="4" name="TextBox 3"/>
+          <p:cNvPr id="5" name="TextBox 4"/>
           <p:cNvSpPr txBox="1"/>
           <p:nvPr/>
         </p:nvSpPr>
@@ -5486,7 +5528,7 @@
       </p:sp>
       <p:sp>
         <p:nvSpPr>
-          <p:cNvPr id="5" name="Rectangle 4"/>
+          <p:cNvPr id="6" name="Rectangle 5"/>
           <p:cNvSpPr/>
           <p:nvPr/>
         </p:nvSpPr>
@@ -5529,7 +5571,7 @@
       </p:sp>
       <p:sp>
         <p:nvSpPr>
-          <p:cNvPr id="6" name="TextBox 5"/>
+          <p:cNvPr id="7" name="TextBox 6"/>
           <p:cNvSpPr txBox="1"/>
           <p:nvPr/>
         </p:nvSpPr>
@@ -5568,7 +5610,7 @@
       </p:sp>
       <p:sp>
         <p:nvSpPr>
-          <p:cNvPr id="7" name="TextBox 6"/>
+          <p:cNvPr id="8" name="TextBox 7"/>
           <p:cNvSpPr txBox="1"/>
           <p:nvPr/>
         </p:nvSpPr>
@@ -5607,7 +5649,7 @@
       </p:sp>
       <p:sp>
         <p:nvSpPr>
-          <p:cNvPr id="8" name="Rounded Rectangle 7"/>
+          <p:cNvPr id="9" name="Rounded Rectangle 8"/>
           <p:cNvSpPr/>
           <p:nvPr/>
         </p:nvSpPr>
@@ -5690,7 +5732,7 @@
       </p:sp>
       <p:sp>
         <p:nvSpPr>
-          <p:cNvPr id="9" name="TextBox 8"/>
+          <p:cNvPr id="10" name="TextBox 9"/>
           <p:cNvSpPr txBox="1"/>
           <p:nvPr/>
         </p:nvSpPr>
@@ -5729,7 +5771,7 @@
       </p:sp>
       <p:sp>
         <p:nvSpPr>
-          <p:cNvPr id="10" name="Rounded Rectangle 9"/>
+          <p:cNvPr id="11" name="Rounded Rectangle 10"/>
           <p:cNvSpPr/>
           <p:nvPr/>
         </p:nvSpPr>
@@ -5812,7 +5854,7 @@
       </p:sp>
       <p:sp>
         <p:nvSpPr>
-          <p:cNvPr id="11" name="TextBox 10"/>
+          <p:cNvPr id="12" name="TextBox 11"/>
           <p:cNvSpPr txBox="1"/>
           <p:nvPr/>
         </p:nvSpPr>
@@ -5851,7 +5893,7 @@
       </p:sp>
       <p:sp>
         <p:nvSpPr>
-          <p:cNvPr id="12" name="Rounded Rectangle 11"/>
+          <p:cNvPr id="13" name="Rounded Rectangle 12"/>
           <p:cNvSpPr/>
           <p:nvPr/>
         </p:nvSpPr>
@@ -5934,7 +5976,7 @@
       </p:sp>
       <p:sp>
         <p:nvSpPr>
-          <p:cNvPr id="13" name="TextBox 12"/>
+          <p:cNvPr id="14" name="TextBox 13"/>
           <p:cNvSpPr txBox="1"/>
           <p:nvPr/>
         </p:nvSpPr>
@@ -5973,7 +6015,7 @@
       </p:sp>
       <p:sp>
         <p:nvSpPr>
-          <p:cNvPr id="14" name="Rounded Rectangle 13"/>
+          <p:cNvPr id="15" name="Rounded Rectangle 14"/>
           <p:cNvSpPr/>
           <p:nvPr/>
         </p:nvSpPr>
@@ -6056,7 +6098,7 @@
       </p:sp>
       <p:sp>
         <p:nvSpPr>
-          <p:cNvPr id="15" name="TextBox 14"/>
+          <p:cNvPr id="16" name="TextBox 15"/>
           <p:cNvSpPr txBox="1"/>
           <p:nvPr/>
         </p:nvSpPr>
@@ -6095,7 +6137,7 @@
       </p:sp>
       <p:sp>
         <p:nvSpPr>
-          <p:cNvPr id="16" name="Rounded Rectangle 15"/>
+          <p:cNvPr id="17" name="Rounded Rectangle 16"/>
           <p:cNvSpPr/>
           <p:nvPr/>
         </p:nvSpPr>
@@ -6178,7 +6220,7 @@
       </p:sp>
       <p:sp>
         <p:nvSpPr>
-          <p:cNvPr id="17" name="Rounded Rectangle 16"/>
+          <p:cNvPr id="18" name="Rounded Rectangle 17"/>
           <p:cNvSpPr/>
           <p:nvPr/>
         </p:nvSpPr>
@@ -6256,15 +6298,39 @@
         <p:nvPr/>
       </p:nvGrpSpPr>
       <p:grpSpPr/>
-      <p:sp>
-        <p:nvSpPr>
-          <p:cNvPr id="2" name="TextBox 1"/>
+      <p:pic>
+        <p:nvPicPr>
+          <p:cNvPr id="2" name="Picture 1" descr="presto-logo.png"/>
+          <p:cNvPicPr>
+            <a:picLocks noChangeAspect="1"/>
+          </p:cNvPicPr>
+          <p:nvPr/>
+        </p:nvPicPr>
+        <p:blipFill>
+          <a:blip r:embed="rId2"/>
+          <a:stretch>
+            <a:fillRect/>
+          </a:stretch>
+        </p:blipFill>
+        <p:spPr>
+          <a:xfrm>
+            <a:off x="502920" y="182880"/>
+            <a:ext cx="420624" cy="420624"/>
+          </a:xfrm>
+          <a:prstGeom prst="rect">
+            <a:avLst/>
+          </a:prstGeom>
+        </p:spPr>
+      </p:pic>
+      <p:sp>
+        <p:nvSpPr>
+          <p:cNvPr id="3" name="TextBox 2"/>
           <p:cNvSpPr txBox="1"/>
           <p:nvPr/>
         </p:nvSpPr>
         <p:spPr>
           <a:xfrm>
-            <a:off x="502920" y="301752"/>
+            <a:off x="1024128" y="301752"/>
             <a:ext cx="2743200" cy="228600"/>
           </a:xfrm>
           <a:prstGeom prst="rect">
@@ -6297,7 +6363,7 @@
       </p:sp>
       <p:sp>
         <p:nvSpPr>
-          <p:cNvPr id="3" name="TextBox 2"/>
+          <p:cNvPr id="4" name="TextBox 3"/>
           <p:cNvSpPr txBox="1"/>
           <p:nvPr/>
         </p:nvSpPr>
@@ -6336,7 +6402,7 @@
       </p:sp>
       <p:sp>
         <p:nvSpPr>
-          <p:cNvPr id="4" name="TextBox 3"/>
+          <p:cNvPr id="5" name="TextBox 4"/>
           <p:cNvSpPr txBox="1"/>
           <p:nvPr/>
         </p:nvSpPr>
@@ -6375,7 +6441,7 @@
       </p:sp>
       <p:sp>
         <p:nvSpPr>
-          <p:cNvPr id="5" name="Rectangle 4"/>
+          <p:cNvPr id="6" name="Rectangle 5"/>
           <p:cNvSpPr/>
           <p:nvPr/>
         </p:nvSpPr>
@@ -6418,7 +6484,7 @@
       </p:sp>
       <p:sp>
         <p:nvSpPr>
-          <p:cNvPr id="6" name="TextBox 5"/>
+          <p:cNvPr id="7" name="TextBox 6"/>
           <p:cNvSpPr txBox="1"/>
           <p:nvPr/>
         </p:nvSpPr>
@@ -6457,7 +6523,7 @@
       </p:sp>
       <p:sp>
         <p:nvSpPr>
-          <p:cNvPr id="7" name="TextBox 6"/>
+          <p:cNvPr id="8" name="TextBox 7"/>
           <p:cNvSpPr txBox="1"/>
           <p:nvPr/>
         </p:nvSpPr>
@@ -6496,7 +6562,7 @@
       </p:sp>
       <p:sp>
         <p:nvSpPr>
-          <p:cNvPr id="8" name="Rounded Rectangle 7"/>
+          <p:cNvPr id="9" name="Rounded Rectangle 8"/>
           <p:cNvSpPr/>
           <p:nvPr/>
         </p:nvSpPr>
@@ -6572,7 +6638,7 @@
       </p:sp>
       <p:sp>
         <p:nvSpPr>
-          <p:cNvPr id="9" name="Rounded Rectangle 8"/>
+          <p:cNvPr id="10" name="Rounded Rectangle 9"/>
           <p:cNvSpPr/>
           <p:nvPr/>
         </p:nvSpPr>
@@ -6648,7 +6714,7 @@
       </p:sp>
       <p:sp>
         <p:nvSpPr>
-          <p:cNvPr id="10" name="Rounded Rectangle 9"/>
+          <p:cNvPr id="11" name="Rounded Rectangle 10"/>
           <p:cNvSpPr/>
           <p:nvPr/>
         </p:nvSpPr>
@@ -6724,7 +6790,7 @@
       </p:sp>
       <p:sp>
         <p:nvSpPr>
-          <p:cNvPr id="11" name="Rounded Rectangle 10"/>
+          <p:cNvPr id="12" name="Rounded Rectangle 11"/>
           <p:cNvSpPr/>
           <p:nvPr/>
         </p:nvSpPr>
@@ -6800,7 +6866,7 @@
       </p:sp>
       <p:sp>
         <p:nvSpPr>
-          <p:cNvPr id="12" name="Rounded Rectangle 11"/>
+          <p:cNvPr id="13" name="Rounded Rectangle 12"/>
           <p:cNvSpPr/>
           <p:nvPr/>
         </p:nvSpPr>
@@ -6878,15 +6944,39 @@
         <p:nvPr/>
       </p:nvGrpSpPr>
       <p:grpSpPr/>
-      <p:sp>
-        <p:nvSpPr>
-          <p:cNvPr id="2" name="TextBox 1"/>
+      <p:pic>
+        <p:nvPicPr>
+          <p:cNvPr id="2" name="Picture 1" descr="presto-logo.png"/>
+          <p:cNvPicPr>
+            <a:picLocks noChangeAspect="1"/>
+          </p:cNvPicPr>
+          <p:nvPr/>
+        </p:nvPicPr>
+        <p:blipFill>
+          <a:blip r:embed="rId2"/>
+          <a:stretch>
+            <a:fillRect/>
+          </a:stretch>
+        </p:blipFill>
+        <p:spPr>
+          <a:xfrm>
+            <a:off x="502920" y="182880"/>
+            <a:ext cx="420624" cy="420624"/>
+          </a:xfrm>
+          <a:prstGeom prst="rect">
+            <a:avLst/>
+          </a:prstGeom>
+        </p:spPr>
+      </p:pic>
+      <p:sp>
+        <p:nvSpPr>
+          <p:cNvPr id="3" name="TextBox 2"/>
           <p:cNvSpPr txBox="1"/>
           <p:nvPr/>
         </p:nvSpPr>
         <p:spPr>
           <a:xfrm>
-            <a:off x="502920" y="301752"/>
+            <a:off x="1024128" y="301752"/>
             <a:ext cx="2743200" cy="228600"/>
           </a:xfrm>
           <a:prstGeom prst="rect">
@@ -6919,7 +7009,7 @@
       </p:sp>
       <p:sp>
         <p:nvSpPr>
-          <p:cNvPr id="3" name="TextBox 2"/>
+          <p:cNvPr id="4" name="TextBox 3"/>
           <p:cNvSpPr txBox="1"/>
           <p:nvPr/>
         </p:nvSpPr>
@@ -6958,7 +7048,7 @@
       </p:sp>
       <p:sp>
         <p:nvSpPr>
-          <p:cNvPr id="4" name="TextBox 3"/>
+          <p:cNvPr id="5" name="TextBox 4"/>
           <p:cNvSpPr txBox="1"/>
           <p:nvPr/>
         </p:nvSpPr>
@@ -6997,7 +7087,7 @@
       </p:sp>
       <p:sp>
         <p:nvSpPr>
-          <p:cNvPr id="5" name="Rectangle 4"/>
+          <p:cNvPr id="6" name="Rectangle 5"/>
           <p:cNvSpPr/>
           <p:nvPr/>
         </p:nvSpPr>
@@ -7040,7 +7130,7 @@
       </p:sp>
       <p:sp>
         <p:nvSpPr>
-          <p:cNvPr id="6" name="TextBox 5"/>
+          <p:cNvPr id="7" name="TextBox 6"/>
           <p:cNvSpPr txBox="1"/>
           <p:nvPr/>
         </p:nvSpPr>
@@ -7079,7 +7169,7 @@
       </p:sp>
       <p:sp>
         <p:nvSpPr>
-          <p:cNvPr id="7" name="TextBox 6"/>
+          <p:cNvPr id="8" name="TextBox 7"/>
           <p:cNvSpPr txBox="1"/>
           <p:nvPr/>
         </p:nvSpPr>
@@ -7118,7 +7208,7 @@
       </p:sp>
       <p:sp>
         <p:nvSpPr>
-          <p:cNvPr id="8" name="Rounded Rectangle 7"/>
+          <p:cNvPr id="9" name="Rounded Rectangle 8"/>
           <p:cNvSpPr/>
           <p:nvPr/>
         </p:nvSpPr>
@@ -7194,7 +7284,7 @@
       </p:sp>
       <p:sp>
         <p:nvSpPr>
-          <p:cNvPr id="9" name="Rounded Rectangle 8"/>
+          <p:cNvPr id="10" name="Rounded Rectangle 9"/>
           <p:cNvSpPr/>
           <p:nvPr/>
         </p:nvSpPr>
@@ -7270,7 +7360,7 @@
       </p:sp>
       <p:sp>
         <p:nvSpPr>
-          <p:cNvPr id="10" name="Rounded Rectangle 9"/>
+          <p:cNvPr id="11" name="Rounded Rectangle 10"/>
           <p:cNvSpPr/>
           <p:nvPr/>
         </p:nvSpPr>
@@ -7346,7 +7436,7 @@
       </p:sp>
       <p:sp>
         <p:nvSpPr>
-          <p:cNvPr id="11" name="Rounded Rectangle 10"/>
+          <p:cNvPr id="12" name="Rounded Rectangle 11"/>
           <p:cNvSpPr/>
           <p:nvPr/>
         </p:nvSpPr>
@@ -7422,7 +7512,7 @@
       </p:sp>
       <p:sp>
         <p:nvSpPr>
-          <p:cNvPr id="12" name="Rounded Rectangle 11"/>
+          <p:cNvPr id="13" name="Rounded Rectangle 12"/>
           <p:cNvSpPr/>
           <p:nvPr/>
         </p:nvSpPr>
@@ -7500,15 +7590,39 @@
         <p:nvPr/>
       </p:nvGrpSpPr>
       <p:grpSpPr/>
-      <p:sp>
-        <p:nvSpPr>
-          <p:cNvPr id="2" name="TextBox 1"/>
+      <p:pic>
+        <p:nvPicPr>
+          <p:cNvPr id="2" name="Picture 1" descr="presto-logo.png"/>
+          <p:cNvPicPr>
+            <a:picLocks noChangeAspect="1"/>
+          </p:cNvPicPr>
+          <p:nvPr/>
+        </p:nvPicPr>
+        <p:blipFill>
+          <a:blip r:embed="rId2"/>
+          <a:stretch>
+            <a:fillRect/>
+          </a:stretch>
+        </p:blipFill>
+        <p:spPr>
+          <a:xfrm>
+            <a:off x="502920" y="182880"/>
+            <a:ext cx="420624" cy="420624"/>
+          </a:xfrm>
+          <a:prstGeom prst="rect">
+            <a:avLst/>
+          </a:prstGeom>
+        </p:spPr>
+      </p:pic>
+      <p:sp>
+        <p:nvSpPr>
+          <p:cNvPr id="3" name="TextBox 2"/>
           <p:cNvSpPr txBox="1"/>
           <p:nvPr/>
         </p:nvSpPr>
         <p:spPr>
           <a:xfrm>
-            <a:off x="502920" y="301752"/>
+            <a:off x="1024128" y="301752"/>
             <a:ext cx="2743200" cy="228600"/>
           </a:xfrm>
           <a:prstGeom prst="rect">
@@ -7541,7 +7655,7 @@
       </p:sp>
       <p:sp>
         <p:nvSpPr>
-          <p:cNvPr id="3" name="TextBox 2"/>
+          <p:cNvPr id="4" name="TextBox 3"/>
           <p:cNvSpPr txBox="1"/>
           <p:nvPr/>
         </p:nvSpPr>
@@ -7580,7 +7694,7 @@
       </p:sp>
       <p:sp>
         <p:nvSpPr>
-          <p:cNvPr id="4" name="TextBox 3"/>
+          <p:cNvPr id="5" name="TextBox 4"/>
           <p:cNvSpPr txBox="1"/>
           <p:nvPr/>
         </p:nvSpPr>
@@ -7619,7 +7733,7 @@
       </p:sp>
       <p:sp>
         <p:nvSpPr>
-          <p:cNvPr id="5" name="Rectangle 4"/>
+          <p:cNvPr id="6" name="Rectangle 5"/>
           <p:cNvSpPr/>
           <p:nvPr/>
         </p:nvSpPr>
@@ -7662,7 +7776,7 @@
       </p:sp>
       <p:sp>
         <p:nvSpPr>
-          <p:cNvPr id="6" name="TextBox 5"/>
+          <p:cNvPr id="7" name="TextBox 6"/>
           <p:cNvSpPr txBox="1"/>
           <p:nvPr/>
         </p:nvSpPr>
@@ -7701,7 +7815,7 @@
       </p:sp>
       <p:sp>
         <p:nvSpPr>
-          <p:cNvPr id="7" name="TextBox 6"/>
+          <p:cNvPr id="8" name="TextBox 7"/>
           <p:cNvSpPr txBox="1"/>
           <p:nvPr/>
         </p:nvSpPr>
@@ -7740,7 +7854,7 @@
       </p:sp>
       <p:sp>
         <p:nvSpPr>
-          <p:cNvPr id="8" name="Rounded Rectangle 7"/>
+          <p:cNvPr id="9" name="Rounded Rectangle 8"/>
           <p:cNvSpPr/>
           <p:nvPr/>
         </p:nvSpPr>
@@ -7808,7 +7922,7 @@
       </p:sp>
       <p:sp>
         <p:nvSpPr>
-          <p:cNvPr id="9" name="Rounded Rectangle 8"/>
+          <p:cNvPr id="10" name="Rounded Rectangle 9"/>
           <p:cNvSpPr/>
           <p:nvPr/>
         </p:nvSpPr>
@@ -7876,7 +7990,7 @@
       </p:sp>
       <p:sp>
         <p:nvSpPr>
-          <p:cNvPr id="10" name="Rounded Rectangle 9"/>
+          <p:cNvPr id="11" name="Rounded Rectangle 10"/>
           <p:cNvSpPr/>
           <p:nvPr/>
         </p:nvSpPr>
@@ -7944,7 +8058,7 @@
       </p:sp>
       <p:sp>
         <p:nvSpPr>
-          <p:cNvPr id="11" name="Rounded Rectangle 10"/>
+          <p:cNvPr id="12" name="Rounded Rectangle 11"/>
           <p:cNvSpPr/>
           <p:nvPr/>
         </p:nvSpPr>
@@ -8012,7 +8126,7 @@
       </p:sp>
       <p:sp>
         <p:nvSpPr>
-          <p:cNvPr id="12" name="TextBox 11"/>
+          <p:cNvPr id="13" name="TextBox 12"/>
           <p:cNvSpPr txBox="1"/>
           <p:nvPr/>
         </p:nvSpPr>
@@ -8053,7 +8167,7 @@
       </p:sp>
       <p:sp>
         <p:nvSpPr>
-          <p:cNvPr id="13" name="Rounded Rectangle 12"/>
+          <p:cNvPr id="14" name="Rounded Rectangle 13"/>
           <p:cNvSpPr/>
           <p:nvPr/>
         </p:nvSpPr>
@@ -8131,50 +8245,30 @@
         <p:nvPr/>
       </p:nvGrpSpPr>
       <p:grpSpPr/>
-      <p:sp>
-        <p:nvSpPr>
-          <p:cNvPr id="2" name="TextBox 1"/>
-          <p:cNvSpPr txBox="1"/>
+      <p:pic>
+        <p:nvPicPr>
+          <p:cNvPr id="2" name="Picture 1" descr="presto-logo.png"/>
+          <p:cNvPicPr>
+            <a:picLocks noChangeAspect="1"/>
+          </p:cNvPicPr>
           <p:nvPr/>
-        </p:nvSpPr>
-        <p:spPr>
-          <a:xfrm>
-            <a:off x="777240" y="1097280"/>
-            <a:ext cx="7772400" cy="960120"/>
+        </p:nvPicPr>
+        <p:blipFill>
+          <a:blip r:embed="rId2"/>
+          <a:stretch>
+            <a:fillRect/>
+          </a:stretch>
+        </p:blipFill>
+        <p:spPr>
+          <a:xfrm>
+            <a:off x="777240" y="777240"/>
+            <a:ext cx="1143000" cy="1143000"/>
           </a:xfrm>
           <a:prstGeom prst="rect">
             <a:avLst/>
           </a:prstGeom>
-          <a:noFill/>
-        </p:spPr>
-        <p:txBody>
-          <a:bodyPr wrap="square" lIns="0" rIns="0" tIns="0" bIns="0">
-            <a:spAutoFit/>
-          </a:bodyPr>
-          <a:lstStyle/>
-          <a:p>
-            <a:pPr algn="l"/>
-            <a:r>
-              <a:rPr sz="5600" b="1">
-                <a:solidFill>
-                  <a:srgbClr val="FFFFFF"/>
-                </a:solidFill>
-                <a:latin typeface="Segoe UI"/>
-              </a:rPr>
-              <a:t>Presto</a:t>
-            </a:r>
-            <a:r>
-              <a:rPr sz="5600" b="1">
-                <a:solidFill>
-                  <a:srgbClr val="93C5FD"/>
-                </a:solidFill>
-                <a:latin typeface="Segoe UI"/>
-              </a:rPr>
-              <a:t>.</a:t>
-            </a:r>
-          </a:p>
-        </p:txBody>
-      </p:sp>
+        </p:spPr>
+      </p:pic>
       <p:sp>
         <p:nvSpPr>
           <p:cNvPr id="3" name="TextBox 2"/>
@@ -8184,7 +8278,7 @@
         <p:spPr>
           <a:xfrm>
             <a:off x="777240" y="1965960"/>
-            <a:ext cx="10789920" cy="640080"/>
+            <a:ext cx="10789920" cy="822960"/>
           </a:xfrm>
           <a:prstGeom prst="rect">
             <a:avLst/>
@@ -8203,13 +8297,13 @@
               </a:lnSpc>
             </a:pPr>
             <a:r>
-              <a:rPr sz="2600" b="0">
-                <a:solidFill>
-                  <a:srgbClr val="DDE9FF"/>
-                </a:solidFill>
-                <a:latin typeface="Segoe UI"/>
-              </a:rPr>
-              <a:t>Menos fricción, más claridad.</a:t>
+              <a:rPr sz="5600" b="1">
+                <a:solidFill>
+                  <a:srgbClr val="FFFFFF"/>
+                </a:solidFill>
+                <a:latin typeface="Segoe UI"/>
+              </a:rPr>
+              <a:t>Presto</a:t>
             </a:r>
           </a:p>
         </p:txBody>
@@ -8222,8 +8316,8 @@
         </p:nvSpPr>
         <p:spPr>
           <a:xfrm>
-            <a:off x="777240" y="3063240"/>
-            <a:ext cx="10789920" cy="320040"/>
+            <a:off x="777240" y="2788920"/>
+            <a:ext cx="10789920" cy="640080"/>
           </a:xfrm>
           <a:prstGeom prst="rect">
             <a:avLst/>
@@ -8242,6 +8336,45 @@
               </a:lnSpc>
             </a:pPr>
             <a:r>
+              <a:rPr sz="2600" b="0">
+                <a:solidFill>
+                  <a:srgbClr val="DDE9FF"/>
+                </a:solidFill>
+                <a:latin typeface="Segoe UI"/>
+              </a:rPr>
+              <a:t>Menos fricción, más claridad.</a:t>
+            </a:r>
+          </a:p>
+        </p:txBody>
+      </p:sp>
+      <p:sp>
+        <p:nvSpPr>
+          <p:cNvPr id="5" name="TextBox 4"/>
+          <p:cNvSpPr txBox="1"/>
+          <p:nvPr/>
+        </p:nvSpPr>
+        <p:spPr>
+          <a:xfrm>
+            <a:off x="777240" y="3063240"/>
+            <a:ext cx="10789920" cy="320040"/>
+          </a:xfrm>
+          <a:prstGeom prst="rect">
+            <a:avLst/>
+          </a:prstGeom>
+          <a:noFill/>
+        </p:spPr>
+        <p:txBody>
+          <a:bodyPr wrap="square" anchor="t" lIns="0" rIns="0" tIns="0" bIns="0">
+            <a:spAutoFit/>
+          </a:bodyPr>
+          <a:lstStyle/>
+          <a:p>
+            <a:pPr algn="l">
+              <a:lnSpc>
+                <a:spcPct val="100000"/>
+              </a:lnSpc>
+            </a:pPr>
+            <a:r>
               <a:rPr sz="1500" b="1">
                 <a:solidFill>
                   <a:srgbClr val="FFFFFF"/>
@@ -8255,7 +8388,7 @@
       </p:sp>
       <p:sp>
         <p:nvSpPr>
-          <p:cNvPr id="5" name="TextBox 4"/>
+          <p:cNvPr id="6" name="TextBox 5"/>
           <p:cNvSpPr txBox="1"/>
           <p:nvPr/>
         </p:nvSpPr>
@@ -8294,7 +8427,7 @@
       </p:sp>
       <p:sp>
         <p:nvSpPr>
-          <p:cNvPr id="6" name="TextBox 5"/>
+          <p:cNvPr id="7" name="TextBox 6"/>
           <p:cNvSpPr txBox="1"/>
           <p:nvPr/>
         </p:nvSpPr>

</xml_diff>